<commit_message>
fix: Slide 1 layout spacing to resolve title text overlapping
</commit_message>
<xml_diff>
--- a/conver_sight_presentation.pptx
+++ b/conver_sight_presentation.pptx
@@ -3113,7 +3113,7 @@
         </p:nvSpPr>
         <p:spPr>
           <a:xfrm>
-            <a:off x="914400" y="1645920"/>
+            <a:off x="914400" y="914400"/>
             <a:ext cx="3657600" cy="365760"/>
           </a:xfrm>
           <a:prstGeom prst="rect">
@@ -3149,8 +3149,8 @@
         </p:nvSpPr>
         <p:spPr>
           <a:xfrm>
-            <a:off x="914400" y="2011680"/>
-            <a:ext cx="10058400" cy="2377440"/>
+            <a:off x="914400" y="1371600"/>
+            <a:ext cx="10058400" cy="3017520"/>
           </a:xfrm>
           <a:prstGeom prst="rect">
             <a:avLst/>
@@ -3158,16 +3158,16 @@
           <a:noFill/>
         </p:spPr>
         <p:txBody>
-          <a:bodyPr wrap="square">
+          <a:bodyPr wrap="square" lIns="0" tIns="0" rIns="0" bIns="0">
             <a:spAutoFit/>
           </a:bodyPr>
           <a:lstStyle/>
           <a:p>
             <a:pPr>
               <a:spcAft>
-                <a:spcPts val="0"/>
+                <a:spcPts val="600"/>
               </a:spcAft>
-              <a:defRPr sz="6400" b="1">
+              <a:defRPr sz="5400" b="1">
                 <a:solidFill>
                   <a:srgbClr val="FFFFFF"/>
                 </a:solidFill>
@@ -3180,7 +3180,10 @@
           </a:p>
           <a:p>
             <a:pPr>
-              <a:defRPr sz="6400" b="1">
+              <a:spcAft>
+                <a:spcPts val="600"/>
+              </a:spcAft>
+              <a:defRPr sz="5400" b="1">
                 <a:solidFill>
                   <a:srgbClr val="FF3300"/>
                 </a:solidFill>
@@ -3188,7 +3191,23 @@
               </a:defRPr>
             </a:pPr>
             <a:r>
-              <a:t>INTELLIGENCE FINDINGS</a:t>
+              <a:t>INTELLIGENCE</a:t>
+            </a:r>
+          </a:p>
+          <a:p>
+            <a:pPr>
+              <a:spcAft>
+                <a:spcPts val="1200"/>
+              </a:spcAft>
+              <a:defRPr sz="5400" b="1">
+                <a:solidFill>
+                  <a:srgbClr val="FF3300"/>
+                </a:solidFill>
+                <a:latin typeface="Archivo"/>
+              </a:defRPr>
+            </a:pPr>
+            <a:r>
+              <a:t>FINDINGS</a:t>
             </a:r>
           </a:p>
         </p:txBody>
@@ -3201,8 +3220,8 @@
         </p:nvSpPr>
         <p:spPr>
           <a:xfrm>
-            <a:off x="914400" y="4297680"/>
-            <a:ext cx="8229600" cy="1097280"/>
+            <a:off x="914400" y="4480560"/>
+            <a:ext cx="8686800" cy="1005840"/>
           </a:xfrm>
           <a:prstGeom prst="rect">
             <a:avLst/>
@@ -3210,13 +3229,16 @@
           <a:noFill/>
         </p:spPr>
         <p:txBody>
-          <a:bodyPr wrap="square">
+          <a:bodyPr wrap="square" lIns="0" tIns="0" rIns="0" bIns="0">
             <a:spAutoFit/>
           </a:bodyPr>
           <a:lstStyle/>
           <a:p>
             <a:pPr>
-              <a:defRPr sz="1800">
+              <a:lnSpc>
+                <a:spcPct val="120000"/>
+              </a:lnSpc>
+              <a:defRPr sz="1600">
                 <a:solidFill>
                   <a:srgbClr val="888888"/>
                 </a:solidFill>
@@ -3237,7 +3259,7 @@
         </p:nvSpPr>
         <p:spPr>
           <a:xfrm>
-            <a:off x="914400" y="5486400"/>
+            <a:off x="914400" y="5623560"/>
             <a:ext cx="5486400" cy="457200"/>
           </a:xfrm>
           <a:prstGeom prst="rect">
@@ -3246,7 +3268,7 @@
           <a:noFill/>
         </p:spPr>
         <p:txBody>
-          <a:bodyPr wrap="none">
+          <a:bodyPr wrap="none" lIns="0" tIns="0" rIns="0" bIns="0">
             <a:spAutoFit/>
           </a:bodyPr>
           <a:lstStyle/>

</xml_diff>